<commit_message>
DOC: NCRB results, PoC scope, verified EDA claims; raw-data download script
</commit_message>
<xml_diff>
--- a/docs/Milestone2_TA_Presentation.pptx
+++ b/docs/Milestone2_TA_Presentation.pptx
@@ -6,19 +6,19 @@
   </p:sldMasterIdLst>
   <p:sldIdLst>
     <p:sldId id="256" r:id="rId7"/>
-    <p:sldId id="257" r:id="rId9"/>
-    <p:sldId id="258" r:id="rId10"/>
-    <p:sldId id="259" r:id="rId11"/>
-    <p:sldId id="260" r:id="rId12"/>
-    <p:sldId id="261" r:id="rId13"/>
-    <p:sldId id="262" r:id="rId14"/>
-    <p:sldId id="263" r:id="rId15"/>
-    <p:sldId id="264" r:id="rId16"/>
-    <p:sldId id="265" r:id="rId17"/>
-    <p:sldId id="266" r:id="rId18"/>
-    <p:sldId id="267" r:id="rId19"/>
-    <p:sldId id="268" r:id="rId20"/>
-    <p:sldId id="269" r:id="rId21"/>
+    <p:sldId id="257" r:id="rId8"/>
+    <p:sldId id="258" r:id="rId9"/>
+    <p:sldId id="259" r:id="rId10"/>
+    <p:sldId id="260" r:id="rId11"/>
+    <p:sldId id="261" r:id="rId12"/>
+    <p:sldId id="262" r:id="rId13"/>
+    <p:sldId id="263" r:id="rId14"/>
+    <p:sldId id="264" r:id="rId15"/>
+    <p:sldId id="265" r:id="rId16"/>
+    <p:sldId id="266" r:id="rId17"/>
+    <p:sldId id="267" r:id="rId18"/>
+    <p:sldId id="268" r:id="rId19"/>
+    <p:sldId id="269" r:id="rId20"/>
   </p:sldIdLst>
   <p:sldSz cx="12191695" cy="6858000" type="screen4x3"/>
   <p:notesSz cx="6858000" cy="9144000"/>
@@ -421,11 +421,16 @@
       <c:valAx>
         <c:axId val="-2113994440"/>
         <c:scaling/>
-        <c:delete/>
+        <c:delete val="0"/>
         <c:axPos val="b"/>
-        <c:majorTickMark val="out"/>
+        <c:majorTickMark val="none"/>
         <c:minorTickMark val="none"/>
-        <c:tickLblPos val="nextTo"/>
+        <c:tickLblPos val="none"/>
+        <c:spPr>
+          <a:ln>
+            <a:noFill/>
+          </a:ln>
+        </c:spPr>
         <c:txPr>
           <a:bodyPr/>
           <a:lstStyle/>
@@ -440,6 +445,7 @@
       </c:valAx>
     </c:plotArea>
     <c:legend>
+      <c:legendPos val="b"/>
       <c:overlay val="0"/>
       <c:txPr>
         <a:bodyPr/>
@@ -611,11 +617,16 @@
       <c:valAx>
         <c:axId val="-2113994440"/>
         <c:scaling/>
-        <c:delete/>
+        <c:delete val="0"/>
         <c:axPos val="l"/>
-        <c:majorTickMark val="out"/>
+        <c:majorTickMark val="none"/>
         <c:minorTickMark val="none"/>
-        <c:tickLblPos val="nextTo"/>
+        <c:tickLblPos val="none"/>
+        <c:spPr>
+          <a:ln>
+            <a:noFill/>
+          </a:ln>
+        </c:spPr>
         <c:crossAx val="-2068027336"/>
         <c:crosses val="autoZero"/>
       </c:valAx>
@@ -636,1336 +647,6 @@
     <c:autoUpdate val="0"/>
   </c:externalData>
 </c:chartSpace>
-</file>
-
-<file path=ppt/notesMasters/notesMaster1.xml><?xml version="1.0" encoding="utf-8"?>
-<p:notesMaster xmlns:a="http://schemas.openxmlformats.org/drawingml/2006/main" xmlns:p="http://schemas.openxmlformats.org/presentationml/2006/main" xmlns:r="http://schemas.openxmlformats.org/officeDocument/2006/relationships">
-  <p:cSld>
-    <p:bg>
-      <p:bgRef idx="1001">
-        <a:schemeClr val="bg1"/>
-      </p:bgRef>
-    </p:bg>
-    <p:spTree>
-      <p:nvGrpSpPr>
-        <p:cNvPr id="1" name=""/>
-        <p:cNvGrpSpPr/>
-        <p:nvPr/>
-      </p:nvGrpSpPr>
-      <p:grpSpPr>
-        <a:xfrm>
-          <a:off x="0" y="0"/>
-          <a:ext cx="0" cy="0"/>
-          <a:chOff x="0" y="0"/>
-          <a:chExt cx="0" cy="0"/>
-        </a:xfrm>
-      </p:grpSpPr>
-      <p:sp>
-        <p:nvSpPr>
-          <p:cNvPr id="2" name="Header Placeholder 1"/>
-          <p:cNvSpPr>
-            <a:spLocks noGrp="1"/>
-          </p:cNvSpPr>
-          <p:nvPr>
-            <p:ph type="hdr" sz="quarter"/>
-          </p:nvPr>
-        </p:nvSpPr>
-        <p:spPr>
-          <a:xfrm>
-            <a:off x="0" y="0"/>
-            <a:ext cx="2971800" cy="457200"/>
-          </a:xfrm>
-          <a:prstGeom prst="rect">
-            <a:avLst/>
-          </a:prstGeom>
-        </p:spPr>
-        <p:txBody>
-          <a:bodyPr vert="horz" lIns="91440" tIns="45720" rIns="91440" bIns="45720" rtlCol="0"/>
-          <a:lstStyle>
-            <a:lvl1pPr algn="l">
-              <a:defRPr sz="1200"/>
-            </a:lvl1pPr>
-          </a:lstStyle>
-          <a:p>
-            <a:endParaRPr lang="en-US"/>
-          </a:p>
-        </p:txBody>
-      </p:sp>
-      <p:sp>
-        <p:nvSpPr>
-          <p:cNvPr id="3" name="Date Placeholder 2"/>
-          <p:cNvSpPr>
-            <a:spLocks noGrp="1"/>
-          </p:cNvSpPr>
-          <p:nvPr>
-            <p:ph type="dt" idx="1"/>
-          </p:nvPr>
-        </p:nvSpPr>
-        <p:spPr>
-          <a:xfrm>
-            <a:off x="3884613" y="0"/>
-            <a:ext cx="2971800" cy="457200"/>
-          </a:xfrm>
-          <a:prstGeom prst="rect">
-            <a:avLst/>
-          </a:prstGeom>
-        </p:spPr>
-        <p:txBody>
-          <a:bodyPr vert="horz" lIns="91440" tIns="45720" rIns="91440" bIns="45720" rtlCol="0"/>
-          <a:lstStyle>
-            <a:lvl1pPr algn="r">
-              <a:defRPr sz="1200"/>
-            </a:lvl1pPr>
-          </a:lstStyle>
-          <a:p>
-            <a:fld id="{0F89C1C7-3DCD-1040-A9CF-14679D8B5DDD}" type="datetimeFigureOut">
-              <a:rPr lang="en-US" smtClean="0"/>
-              <a:t>10/17/16</a:t>
-            </a:fld>
-            <a:endParaRPr lang="en-US"/>
-          </a:p>
-        </p:txBody>
-      </p:sp>
-      <p:sp>
-        <p:nvSpPr>
-          <p:cNvPr id="4" name="Slide Image Placeholder 3"/>
-          <p:cNvSpPr>
-            <a:spLocks noGrp="1" noRot="1" noChangeAspect="1"/>
-          </p:cNvSpPr>
-          <p:nvPr>
-            <p:ph type="sldImg" idx="2"/>
-          </p:nvPr>
-        </p:nvSpPr>
-        <p:spPr>
-          <a:xfrm>
-            <a:off x="1143000" y="685800"/>
-            <a:ext cx="4572000" cy="3429000"/>
-          </a:xfrm>
-          <a:prstGeom prst="rect">
-            <a:avLst/>
-          </a:prstGeom>
-          <a:noFill/>
-          <a:ln w="12700">
-            <a:solidFill>
-              <a:prstClr val="black"/>
-            </a:solidFill>
-          </a:ln>
-        </p:spPr>
-        <p:txBody>
-          <a:bodyPr vert="horz" lIns="91440" tIns="45720" rIns="91440" bIns="45720" rtlCol="0" anchor="ctr"/>
-          <a:lstStyle/>
-          <a:p>
-            <a:endParaRPr lang="en-US"/>
-          </a:p>
-        </p:txBody>
-      </p:sp>
-      <p:sp>
-        <p:nvSpPr>
-          <p:cNvPr id="5" name="Notes Placeholder 4"/>
-          <p:cNvSpPr>
-            <a:spLocks noGrp="1"/>
-          </p:cNvSpPr>
-          <p:nvPr>
-            <p:ph type="body" sz="quarter" idx="3"/>
-          </p:nvPr>
-        </p:nvSpPr>
-        <p:spPr>
-          <a:xfrm>
-            <a:off x="685800" y="4343400"/>
-            <a:ext cx="5486400" cy="4114800"/>
-          </a:xfrm>
-          <a:prstGeom prst="rect">
-            <a:avLst/>
-          </a:prstGeom>
-        </p:spPr>
-        <p:txBody>
-          <a:bodyPr vert="horz" lIns="91440" tIns="45720" rIns="91440" bIns="45720" rtlCol="0"/>
-          <a:lstStyle/>
-          <a:p>
-            <a:pPr lvl="0"/>
-            <a:r>
-              <a:rPr lang="en-US" smtClean="0"/>
-              <a:t>Click to edit Master text styles</a:t>
-            </a:r>
-          </a:p>
-          <a:p>
-            <a:pPr lvl="1"/>
-            <a:r>
-              <a:rPr lang="en-US" smtClean="0"/>
-              <a:t>Second level</a:t>
-            </a:r>
-          </a:p>
-          <a:p>
-            <a:pPr lvl="2"/>
-            <a:r>
-              <a:rPr lang="en-US" smtClean="0"/>
-              <a:t>Third level</a:t>
-            </a:r>
-          </a:p>
-          <a:p>
-            <a:pPr lvl="3"/>
-            <a:r>
-              <a:rPr lang="en-US" smtClean="0"/>
-              <a:t>Fourth level</a:t>
-            </a:r>
-          </a:p>
-          <a:p>
-            <a:pPr lvl="4"/>
-            <a:r>
-              <a:rPr lang="en-US" smtClean="0"/>
-              <a:t>Fifth level</a:t>
-            </a:r>
-            <a:endParaRPr lang="en-US"/>
-          </a:p>
-        </p:txBody>
-      </p:sp>
-      <p:sp>
-        <p:nvSpPr>
-          <p:cNvPr id="6" name="Footer Placeholder 5"/>
-          <p:cNvSpPr>
-            <a:spLocks noGrp="1"/>
-          </p:cNvSpPr>
-          <p:nvPr>
-            <p:ph type="ftr" sz="quarter" idx="4"/>
-          </p:nvPr>
-        </p:nvSpPr>
-        <p:spPr>
-          <a:xfrm>
-            <a:off x="0" y="8685213"/>
-            <a:ext cx="2971800" cy="457200"/>
-          </a:xfrm>
-          <a:prstGeom prst="rect">
-            <a:avLst/>
-          </a:prstGeom>
-        </p:spPr>
-        <p:txBody>
-          <a:bodyPr vert="horz" lIns="91440" tIns="45720" rIns="91440" bIns="45720" rtlCol="0" anchor="b"/>
-          <a:lstStyle>
-            <a:lvl1pPr algn="l">
-              <a:defRPr sz="1200"/>
-            </a:lvl1pPr>
-          </a:lstStyle>
-          <a:p>
-            <a:endParaRPr lang="en-US"/>
-          </a:p>
-        </p:txBody>
-      </p:sp>
-      <p:sp>
-        <p:nvSpPr>
-          <p:cNvPr id="7" name="Slide Number Placeholder 6"/>
-          <p:cNvSpPr>
-            <a:spLocks noGrp="1"/>
-          </p:cNvSpPr>
-          <p:nvPr>
-            <p:ph type="sldNum" sz="quarter" idx="5"/>
-          </p:nvPr>
-        </p:nvSpPr>
-        <p:spPr>
-          <a:xfrm>
-            <a:off x="3884613" y="8685213"/>
-            <a:ext cx="2971800" cy="457200"/>
-          </a:xfrm>
-          <a:prstGeom prst="rect">
-            <a:avLst/>
-          </a:prstGeom>
-        </p:spPr>
-        <p:txBody>
-          <a:bodyPr vert="horz" lIns="91440" tIns="45720" rIns="91440" bIns="45720" rtlCol="0" anchor="b"/>
-          <a:lstStyle>
-            <a:lvl1pPr algn="r">
-              <a:defRPr sz="1200"/>
-            </a:lvl1pPr>
-          </a:lstStyle>
-          <a:p>
-            <a:fld id="{BB5E49A5-4136-284D-997B-48E1D791AD67}" type="slidenum">
-              <a:rPr lang="en-US" smtClean="0"/>
-              <a:t>‹#›</a:t>
-            </a:fld>
-            <a:endParaRPr lang="en-US"/>
-          </a:p>
-        </p:txBody>
-      </p:sp>
-    </p:spTree>
-    <p:extLst>
-      <p:ext uri="{BB962C8B-B14F-4D97-AF65-F5344CB8AC3E}">
-        <p14:creationId xmlns:p14="http://schemas.microsoft.com/office/powerpoint/2010/main" val="2623252185"/>
-      </p:ext>
-    </p:extLst>
-  </p:cSld>
-  <p:clrMap bg1="lt1" tx1="dk1" bg2="lt2" tx2="dk2" accent1="accent1" accent2="accent2" accent3="accent3" accent4="accent4" accent5="accent5" accent6="accent6" hlink="hlink" folHlink="folHlink"/>
-  <p:notesStyle>
-    <a:lvl1pPr marL="0" algn="l" defTabSz="457200" rtl="0" eaLnBrk="1" latinLnBrk="0" hangingPunct="1">
-      <a:defRPr sz="1200" kern="1200">
-        <a:solidFill>
-          <a:schemeClr val="tx1"/>
-        </a:solidFill>
-        <a:latin typeface="+mn-lt"/>
-        <a:ea typeface="+mn-ea"/>
-        <a:cs typeface="+mn-cs"/>
-      </a:defRPr>
-    </a:lvl1pPr>
-    <a:lvl2pPr marL="457200" algn="l" defTabSz="457200" rtl="0" eaLnBrk="1" latinLnBrk="0" hangingPunct="1">
-      <a:defRPr sz="1200" kern="1200">
-        <a:solidFill>
-          <a:schemeClr val="tx1"/>
-        </a:solidFill>
-        <a:latin typeface="+mn-lt"/>
-        <a:ea typeface="+mn-ea"/>
-        <a:cs typeface="+mn-cs"/>
-      </a:defRPr>
-    </a:lvl2pPr>
-    <a:lvl3pPr marL="914400" algn="l" defTabSz="457200" rtl="0" eaLnBrk="1" latinLnBrk="0" hangingPunct="1">
-      <a:defRPr sz="1200" kern="1200">
-        <a:solidFill>
-          <a:schemeClr val="tx1"/>
-        </a:solidFill>
-        <a:latin typeface="+mn-lt"/>
-        <a:ea typeface="+mn-ea"/>
-        <a:cs typeface="+mn-cs"/>
-      </a:defRPr>
-    </a:lvl3pPr>
-    <a:lvl4pPr marL="1371600" algn="l" defTabSz="457200" rtl="0" eaLnBrk="1" latinLnBrk="0" hangingPunct="1">
-      <a:defRPr sz="1200" kern="1200">
-        <a:solidFill>
-          <a:schemeClr val="tx1"/>
-        </a:solidFill>
-        <a:latin typeface="+mn-lt"/>
-        <a:ea typeface="+mn-ea"/>
-        <a:cs typeface="+mn-cs"/>
-      </a:defRPr>
-    </a:lvl4pPr>
-    <a:lvl5pPr marL="1828800" algn="l" defTabSz="457200" rtl="0" eaLnBrk="1" latinLnBrk="0" hangingPunct="1">
-      <a:defRPr sz="1200" kern="1200">
-        <a:solidFill>
-          <a:schemeClr val="tx1"/>
-        </a:solidFill>
-        <a:latin typeface="+mn-lt"/>
-        <a:ea typeface="+mn-ea"/>
-        <a:cs typeface="+mn-cs"/>
-      </a:defRPr>
-    </a:lvl5pPr>
-    <a:lvl6pPr marL="2286000" algn="l" defTabSz="457200" rtl="0" eaLnBrk="1" latinLnBrk="0" hangingPunct="1">
-      <a:defRPr sz="1200" kern="1200">
-        <a:solidFill>
-          <a:schemeClr val="tx1"/>
-        </a:solidFill>
-        <a:latin typeface="+mn-lt"/>
-        <a:ea typeface="+mn-ea"/>
-        <a:cs typeface="+mn-cs"/>
-      </a:defRPr>
-    </a:lvl6pPr>
-    <a:lvl7pPr marL="2743200" algn="l" defTabSz="457200" rtl="0" eaLnBrk="1" latinLnBrk="0" hangingPunct="1">
-      <a:defRPr sz="1200" kern="1200">
-        <a:solidFill>
-          <a:schemeClr val="tx1"/>
-        </a:solidFill>
-        <a:latin typeface="+mn-lt"/>
-        <a:ea typeface="+mn-ea"/>
-        <a:cs typeface="+mn-cs"/>
-      </a:defRPr>
-    </a:lvl7pPr>
-    <a:lvl8pPr marL="3200400" algn="l" defTabSz="457200" rtl="0" eaLnBrk="1" latinLnBrk="0" hangingPunct="1">
-      <a:defRPr sz="1200" kern="1200">
-        <a:solidFill>
-          <a:schemeClr val="tx1"/>
-        </a:solidFill>
-        <a:latin typeface="+mn-lt"/>
-        <a:ea typeface="+mn-ea"/>
-        <a:cs typeface="+mn-cs"/>
-      </a:defRPr>
-    </a:lvl8pPr>
-    <a:lvl9pPr marL="3657600" algn="l" defTabSz="457200" rtl="0" eaLnBrk="1" latinLnBrk="0" hangingPunct="1">
-      <a:defRPr sz="1200" kern="1200">
-        <a:solidFill>
-          <a:schemeClr val="tx1"/>
-        </a:solidFill>
-        <a:latin typeface="+mn-lt"/>
-        <a:ea typeface="+mn-ea"/>
-        <a:cs typeface="+mn-cs"/>
-      </a:defRPr>
-    </a:lvl9pPr>
-  </p:notesStyle>
-</p:notesMaster>
-</file>
-
-<file path=ppt/notesSlides/notesSlide1.xml><?xml version="1.0" encoding="utf-8"?>
-<p:notes xmlns:a="http://schemas.openxmlformats.org/drawingml/2006/main" xmlns:p="http://schemas.openxmlformats.org/presentationml/2006/main" xmlns:r="http://schemas.openxmlformats.org/officeDocument/2006/relationships">
-  <p:cSld>
-    <p:spTree>
-      <p:nvGrpSpPr>
-        <p:cNvPr id="1" name=""/>
-        <p:cNvGrpSpPr/>
-        <p:nvPr/>
-      </p:nvGrpSpPr>
-      <p:grpSpPr>
-        <a:xfrm>
-          <a:off x="0" y="0"/>
-          <a:ext cx="0" cy="0"/>
-          <a:chOff x="0" y="0"/>
-          <a:chExt cx="0" cy="0"/>
-        </a:xfrm>
-      </p:grpSpPr>
-      <p:sp>
-        <p:nvSpPr>
-          <p:cNvPr id="2" name="Slide Image Placeholder 1"/>
-          <p:cNvSpPr>
-            <a:spLocks noGrp="1"/>
-          </p:cNvSpPr>
-          <p:nvPr>
-            <p:ph type="sldImg" idx="2"/>
-          </p:nvPr>
-        </p:nvSpPr>
-        <p:spPr/>
-      </p:sp>
-      <p:sp>
-        <p:nvSpPr>
-          <p:cNvPr id="3" name="Notes Placeholder 2"/>
-          <p:cNvSpPr>
-            <a:spLocks noGrp="1"/>
-          </p:cNvSpPr>
-          <p:nvPr>
-            <p:ph type="body" idx="3" sz="quarter"/>
-          </p:nvPr>
-        </p:nvSpPr>
-        <p:spPr/>
-        <p:txBody>
-          <a:bodyPr/>
-          <a:lstStyle/>
-          <a:p>
-            <a:r>
-              <a:t>Milestone 2 review: dataset identification and data preparation.</a:t>
-            </a:r>
-          </a:p>
-        </p:txBody>
-      </p:sp>
-      <p:sp>
-        <p:nvSpPr>
-          <p:cNvPr id="4" name="Slide Number Placeholder 3"/>
-          <p:cNvSpPr>
-            <a:spLocks noGrp="1"/>
-          </p:cNvSpPr>
-          <p:nvPr>
-            <p:ph type="sldNum" idx="5" sz="quarter"/>
-          </p:nvPr>
-        </p:nvSpPr>
-        <p:spPr/>
-      </p:sp>
-    </p:spTree>
-  </p:cSld>
-  <p:clrMapOvr>
-    <a:masterClrMapping/>
-  </p:clrMapOvr>
-</p:notes>
-</file>
-
-<file path=ppt/notesSlides/notesSlide10.xml><?xml version="1.0" encoding="utf-8"?>
-<p:notes xmlns:a="http://schemas.openxmlformats.org/drawingml/2006/main" xmlns:p="http://schemas.openxmlformats.org/presentationml/2006/main" xmlns:r="http://schemas.openxmlformats.org/officeDocument/2006/relationships">
-  <p:cSld>
-    <p:spTree>
-      <p:nvGrpSpPr>
-        <p:cNvPr id="1" name=""/>
-        <p:cNvGrpSpPr/>
-        <p:nvPr/>
-      </p:nvGrpSpPr>
-      <p:grpSpPr>
-        <a:xfrm>
-          <a:off x="0" y="0"/>
-          <a:ext cx="0" cy="0"/>
-          <a:chOff x="0" y="0"/>
-          <a:chExt cx="0" cy="0"/>
-        </a:xfrm>
-      </p:grpSpPr>
-      <p:sp>
-        <p:nvSpPr>
-          <p:cNvPr id="2" name="Slide Image Placeholder 1"/>
-          <p:cNvSpPr>
-            <a:spLocks noGrp="1"/>
-          </p:cNvSpPr>
-          <p:nvPr>
-            <p:ph type="sldImg" idx="2"/>
-          </p:nvPr>
-        </p:nvSpPr>
-        <p:spPr/>
-      </p:sp>
-      <p:sp>
-        <p:nvSpPr>
-          <p:cNvPr id="3" name="Notes Placeholder 2"/>
-          <p:cNvSpPr>
-            <a:spLocks noGrp="1"/>
-          </p:cNvSpPr>
-          <p:nvPr>
-            <p:ph type="body" idx="3" sz="quarter"/>
-          </p:nvPr>
-        </p:nvSpPr>
-        <p:spPr/>
-        <p:txBody>
-          <a:bodyPr/>
-          <a:lstStyle/>
-          <a:p>
-            <a:r>
-              <a:t>Routing split by group_id; reference pairs split by (dataset, category) template.</a:t>
-            </a:r>
-          </a:p>
-        </p:txBody>
-      </p:sp>
-      <p:sp>
-        <p:nvSpPr>
-          <p:cNvPr id="4" name="Slide Number Placeholder 3"/>
-          <p:cNvSpPr>
-            <a:spLocks noGrp="1"/>
-          </p:cNvSpPr>
-          <p:nvPr>
-            <p:ph type="sldNum" idx="5" sz="quarter"/>
-          </p:nvPr>
-        </p:nvSpPr>
-        <p:spPr/>
-      </p:sp>
-    </p:spTree>
-  </p:cSld>
-  <p:clrMapOvr>
-    <a:masterClrMapping/>
-  </p:clrMapOvr>
-</p:notes>
-</file>
-
-<file path=ppt/notesSlides/notesSlide11.xml><?xml version="1.0" encoding="utf-8"?>
-<p:notes xmlns:a="http://schemas.openxmlformats.org/drawingml/2006/main" xmlns:p="http://schemas.openxmlformats.org/presentationml/2006/main" xmlns:r="http://schemas.openxmlformats.org/officeDocument/2006/relationships">
-  <p:cSld>
-    <p:spTree>
-      <p:nvGrpSpPr>
-        <p:cNvPr id="1" name=""/>
-        <p:cNvGrpSpPr/>
-        <p:nvPr/>
-      </p:nvGrpSpPr>
-      <p:grpSpPr>
-        <a:xfrm>
-          <a:off x="0" y="0"/>
-          <a:ext cx="0" cy="0"/>
-          <a:chOff x="0" y="0"/>
-          <a:chExt cx="0" cy="0"/>
-        </a:xfrm>
-      </p:grpSpPr>
-      <p:sp>
-        <p:nvSpPr>
-          <p:cNvPr id="2" name="Slide Image Placeholder 1"/>
-          <p:cNvSpPr>
-            <a:spLocks noGrp="1"/>
-          </p:cNvSpPr>
-          <p:nvPr>
-            <p:ph type="sldImg" idx="2"/>
-          </p:nvPr>
-        </p:nvSpPr>
-        <p:spPr/>
-      </p:sp>
-      <p:sp>
-        <p:nvSpPr>
-          <p:cNvPr id="3" name="Notes Placeholder 2"/>
-          <p:cNvSpPr>
-            <a:spLocks noGrp="1"/>
-          </p:cNvSpPr>
-          <p:nvPr>
-            <p:ph type="body" idx="3" sz="quarter"/>
-          </p:nvPr>
-        </p:nvSpPr>
-        <p:spPr/>
-        <p:txBody>
-          <a:bodyPr/>
-          <a:lstStyle/>
-          <a:p>
-            <a:r>
-              <a:t>Expected action and abstention cause separate data gaps from system errors (M1 review point).</a:t>
-            </a:r>
-          </a:p>
-        </p:txBody>
-      </p:sp>
-      <p:sp>
-        <p:nvSpPr>
-          <p:cNvPr id="4" name="Slide Number Placeholder 3"/>
-          <p:cNvSpPr>
-            <a:spLocks noGrp="1"/>
-          </p:cNvSpPr>
-          <p:nvPr>
-            <p:ph type="sldNum" idx="5" sz="quarter"/>
-          </p:nvPr>
-        </p:nvSpPr>
-        <p:spPr/>
-      </p:sp>
-    </p:spTree>
-  </p:cSld>
-  <p:clrMapOvr>
-    <a:masterClrMapping/>
-  </p:clrMapOvr>
-</p:notes>
-</file>
-
-<file path=ppt/notesSlides/notesSlide12.xml><?xml version="1.0" encoding="utf-8"?>
-<p:notes xmlns:a="http://schemas.openxmlformats.org/drawingml/2006/main" xmlns:p="http://schemas.openxmlformats.org/presentationml/2006/main" xmlns:r="http://schemas.openxmlformats.org/officeDocument/2006/relationships">
-  <p:cSld>
-    <p:spTree>
-      <p:nvGrpSpPr>
-        <p:cNvPr id="1" name=""/>
-        <p:cNvGrpSpPr/>
-        <p:nvPr/>
-      </p:nvGrpSpPr>
-      <p:grpSpPr>
-        <a:xfrm>
-          <a:off x="0" y="0"/>
-          <a:ext cx="0" cy="0"/>
-          <a:chOff x="0" y="0"/>
-          <a:chExt cx="0" cy="0"/>
-        </a:xfrm>
-      </p:grpSpPr>
-      <p:sp>
-        <p:nvSpPr>
-          <p:cNvPr id="2" name="Slide Image Placeholder 1"/>
-          <p:cNvSpPr>
-            <a:spLocks noGrp="1"/>
-          </p:cNvSpPr>
-          <p:nvPr>
-            <p:ph type="sldImg" idx="2"/>
-          </p:nvPr>
-        </p:nvSpPr>
-        <p:spPr/>
-      </p:sp>
-      <p:sp>
-        <p:nvSpPr>
-          <p:cNvPr id="3" name="Notes Placeholder 2"/>
-          <p:cNvSpPr>
-            <a:spLocks noGrp="1"/>
-          </p:cNvSpPr>
-          <p:nvPr>
-            <p:ph type="body" idx="3" sz="quarter"/>
-          </p:nvPr>
-        </p:nvSpPr>
-        <p:spPr/>
-        <p:txBody>
-          <a:bodyPr/>
-          <a:lstStyle/>
-          <a:p>
-            <a:r>
-              <a:t>Routing figures are preliminary (teacher-written labels).</a:t>
-            </a:r>
-          </a:p>
-        </p:txBody>
-      </p:sp>
-      <p:sp>
-        <p:nvSpPr>
-          <p:cNvPr id="4" name="Slide Number Placeholder 3"/>
-          <p:cNvSpPr>
-            <a:spLocks noGrp="1"/>
-          </p:cNvSpPr>
-          <p:nvPr>
-            <p:ph type="sldNum" idx="5" sz="quarter"/>
-          </p:nvPr>
-        </p:nvSpPr>
-        <p:spPr/>
-      </p:sp>
-    </p:spTree>
-  </p:cSld>
-  <p:clrMapOvr>
-    <a:masterClrMapping/>
-  </p:clrMapOvr>
-</p:notes>
-</file>
-
-<file path=ppt/notesSlides/notesSlide13.xml><?xml version="1.0" encoding="utf-8"?>
-<p:notes xmlns:a="http://schemas.openxmlformats.org/drawingml/2006/main" xmlns:p="http://schemas.openxmlformats.org/presentationml/2006/main" xmlns:r="http://schemas.openxmlformats.org/officeDocument/2006/relationships">
-  <p:cSld>
-    <p:spTree>
-      <p:nvGrpSpPr>
-        <p:cNvPr id="1" name=""/>
-        <p:cNvGrpSpPr/>
-        <p:nvPr/>
-      </p:nvGrpSpPr>
-      <p:grpSpPr>
-        <a:xfrm>
-          <a:off x="0" y="0"/>
-          <a:ext cx="0" cy="0"/>
-          <a:chOff x="0" y="0"/>
-          <a:chExt cx="0" cy="0"/>
-        </a:xfrm>
-      </p:grpSpPr>
-      <p:sp>
-        <p:nvSpPr>
-          <p:cNvPr id="2" name="Slide Image Placeholder 1"/>
-          <p:cNvSpPr>
-            <a:spLocks noGrp="1"/>
-          </p:cNvSpPr>
-          <p:nvPr>
-            <p:ph type="sldImg" idx="2"/>
-          </p:nvPr>
-        </p:nvSpPr>
-        <p:spPr/>
-      </p:sp>
-      <p:sp>
-        <p:nvSpPr>
-          <p:cNvPr id="3" name="Notes Placeholder 2"/>
-          <p:cNvSpPr>
-            <a:spLocks noGrp="1"/>
-          </p:cNvSpPr>
-          <p:nvPr>
-            <p:ph type="body" idx="3" sz="quarter"/>
-          </p:nvPr>
-        </p:nvSpPr>
-        <p:spPr/>
-        <p:txBody>
-          <a:bodyPr/>
-          <a:lstStyle/>
-          <a:p>
-            <a:r>
-              <a:t>Ready for Kev-0.8B routing fine-tuning and for the v0 baseline evaluation.</a:t>
-            </a:r>
-          </a:p>
-        </p:txBody>
-      </p:sp>
-      <p:sp>
-        <p:nvSpPr>
-          <p:cNvPr id="4" name="Slide Number Placeholder 3"/>
-          <p:cNvSpPr>
-            <a:spLocks noGrp="1"/>
-          </p:cNvSpPr>
-          <p:nvPr>
-            <p:ph type="sldNum" idx="5" sz="quarter"/>
-          </p:nvPr>
-        </p:nvSpPr>
-        <p:spPr/>
-      </p:sp>
-    </p:spTree>
-  </p:cSld>
-  <p:clrMapOvr>
-    <a:masterClrMapping/>
-  </p:clrMapOvr>
-</p:notes>
-</file>
-
-<file path=ppt/notesSlides/notesSlide14.xml><?xml version="1.0" encoding="utf-8"?>
-<p:notes xmlns:a="http://schemas.openxmlformats.org/drawingml/2006/main" xmlns:p="http://schemas.openxmlformats.org/presentationml/2006/main" xmlns:r="http://schemas.openxmlformats.org/officeDocument/2006/relationships">
-  <p:cSld>
-    <p:spTree>
-      <p:nvGrpSpPr>
-        <p:cNvPr id="1" name=""/>
-        <p:cNvGrpSpPr/>
-        <p:nvPr/>
-      </p:nvGrpSpPr>
-      <p:grpSpPr>
-        <a:xfrm>
-          <a:off x="0" y="0"/>
-          <a:ext cx="0" cy="0"/>
-          <a:chOff x="0" y="0"/>
-          <a:chExt cx="0" cy="0"/>
-        </a:xfrm>
-      </p:grpSpPr>
-      <p:sp>
-        <p:nvSpPr>
-          <p:cNvPr id="2" name="Slide Image Placeholder 1"/>
-          <p:cNvSpPr>
-            <a:spLocks noGrp="1"/>
-          </p:cNvSpPr>
-          <p:nvPr>
-            <p:ph type="sldImg" idx="2"/>
-          </p:nvPr>
-        </p:nvSpPr>
-        <p:spPr/>
-      </p:sp>
-      <p:sp>
-        <p:nvSpPr>
-          <p:cNvPr id="3" name="Notes Placeholder 2"/>
-          <p:cNvSpPr>
-            <a:spLocks noGrp="1"/>
-          </p:cNvSpPr>
-          <p:nvPr>
-            <p:ph type="body" idx="3" sz="quarter"/>
-          </p:nvPr>
-        </p:nvSpPr>
-        <p:spPr/>
-        <p:txBody>
-          <a:bodyPr/>
-          <a:lstStyle/>
-          <a:p>
-            <a:r>
-              <a:t>Contribution details and evidence links in WORKLOG.md; approvals recorded in the report's sign-off table.</a:t>
-            </a:r>
-          </a:p>
-        </p:txBody>
-      </p:sp>
-      <p:sp>
-        <p:nvSpPr>
-          <p:cNvPr id="4" name="Slide Number Placeholder 3"/>
-          <p:cNvSpPr>
-            <a:spLocks noGrp="1"/>
-          </p:cNvSpPr>
-          <p:nvPr>
-            <p:ph type="sldNum" idx="5" sz="quarter"/>
-          </p:nvPr>
-        </p:nvSpPr>
-        <p:spPr/>
-      </p:sp>
-    </p:spTree>
-  </p:cSld>
-  <p:clrMapOvr>
-    <a:masterClrMapping/>
-  </p:clrMapOvr>
-</p:notes>
-</file>
-
-<file path=ppt/notesSlides/notesSlide2.xml><?xml version="1.0" encoding="utf-8"?>
-<p:notes xmlns:a="http://schemas.openxmlformats.org/drawingml/2006/main" xmlns:p="http://schemas.openxmlformats.org/presentationml/2006/main" xmlns:r="http://schemas.openxmlformats.org/officeDocument/2006/relationships">
-  <p:cSld>
-    <p:spTree>
-      <p:nvGrpSpPr>
-        <p:cNvPr id="1" name=""/>
-        <p:cNvGrpSpPr/>
-        <p:nvPr/>
-      </p:nvGrpSpPr>
-      <p:grpSpPr>
-        <a:xfrm>
-          <a:off x="0" y="0"/>
-          <a:ext cx="0" cy="0"/>
-          <a:chOff x="0" y="0"/>
-          <a:chExt cx="0" cy="0"/>
-        </a:xfrm>
-      </p:grpSpPr>
-      <p:sp>
-        <p:nvSpPr>
-          <p:cNvPr id="2" name="Slide Image Placeholder 1"/>
-          <p:cNvSpPr>
-            <a:spLocks noGrp="1"/>
-          </p:cNvSpPr>
-          <p:nvPr>
-            <p:ph type="sldImg" idx="2"/>
-          </p:nvPr>
-        </p:nvSpPr>
-        <p:spPr/>
-      </p:sp>
-      <p:sp>
-        <p:nvSpPr>
-          <p:cNvPr id="3" name="Notes Placeholder 2"/>
-          <p:cNvSpPr>
-            <a:spLocks noGrp="1"/>
-          </p:cNvSpPr>
-          <p:nvPr>
-            <p:ph type="body" idx="3" sz="quarter"/>
-          </p:nvPr>
-        </p:nvSpPr>
-        <p:spPr/>
-        <p:txBody>
-          <a:bodyPr/>
-          <a:lstStyle/>
-          <a:p>
-            <a:r>
-              <a:t>Five tables cleaned and profiled; two label sets prepared and split with leakage checks.</a:t>
-            </a:r>
-          </a:p>
-        </p:txBody>
-      </p:sp>
-      <p:sp>
-        <p:nvSpPr>
-          <p:cNvPr id="4" name="Slide Number Placeholder 3"/>
-          <p:cNvSpPr>
-            <a:spLocks noGrp="1"/>
-          </p:cNvSpPr>
-          <p:nvPr>
-            <p:ph type="sldNum" idx="5" sz="quarter"/>
-          </p:nvPr>
-        </p:nvSpPr>
-        <p:spPr/>
-      </p:sp>
-    </p:spTree>
-  </p:cSld>
-  <p:clrMapOvr>
-    <a:masterClrMapping/>
-  </p:clrMapOvr>
-</p:notes>
-</file>
-
-<file path=ppt/notesSlides/notesSlide3.xml><?xml version="1.0" encoding="utf-8"?>
-<p:notes xmlns:a="http://schemas.openxmlformats.org/drawingml/2006/main" xmlns:p="http://schemas.openxmlformats.org/presentationml/2006/main" xmlns:r="http://schemas.openxmlformats.org/officeDocument/2006/relationships">
-  <p:cSld>
-    <p:spTree>
-      <p:nvGrpSpPr>
-        <p:cNvPr id="1" name=""/>
-        <p:cNvGrpSpPr/>
-        <p:nvPr/>
-      </p:nvGrpSpPr>
-      <p:grpSpPr>
-        <a:xfrm>
-          <a:off x="0" y="0"/>
-          <a:ext cx="0" cy="0"/>
-          <a:chOff x="0" y="0"/>
-          <a:chExt cx="0" cy="0"/>
-        </a:xfrm>
-      </p:grpSpPr>
-      <p:sp>
-        <p:nvSpPr>
-          <p:cNvPr id="2" name="Slide Image Placeholder 1"/>
-          <p:cNvSpPr>
-            <a:spLocks noGrp="1"/>
-          </p:cNvSpPr>
-          <p:nvPr>
-            <p:ph type="sldImg" idx="2"/>
-          </p:nvPr>
-        </p:nvSpPr>
-        <p:spPr/>
-      </p:sp>
-      <p:sp>
-        <p:nvSpPr>
-          <p:cNvPr id="3" name="Notes Placeholder 2"/>
-          <p:cNvSpPr>
-            <a:spLocks noGrp="1"/>
-          </p:cNvSpPr>
-          <p:nvPr>
-            <p:ph type="body" idx="3" sz="quarter"/>
-          </p:nvPr>
-        </p:nvSpPr>
-        <p:spPr/>
-        <p:txBody>
-          <a:bodyPr/>
-          <a:lstStyle/>
-          <a:p>
-            <a:r>
-              <a:t>All from data.gov.in under the Government Open Data License - India; IDs in the report, Section 2.</a:t>
-            </a:r>
-          </a:p>
-        </p:txBody>
-      </p:sp>
-      <p:sp>
-        <p:nvSpPr>
-          <p:cNvPr id="4" name="Slide Number Placeholder 3"/>
-          <p:cNvSpPr>
-            <a:spLocks noGrp="1"/>
-          </p:cNvSpPr>
-          <p:nvPr>
-            <p:ph type="sldNum" idx="5" sz="quarter"/>
-          </p:nvPr>
-        </p:nvSpPr>
-        <p:spPr/>
-      </p:sp>
-    </p:spTree>
-  </p:cSld>
-  <p:clrMapOvr>
-    <a:masterClrMapping/>
-  </p:clrMapOvr>
-</p:notes>
-</file>
-
-<file path=ppt/notesSlides/notesSlide4.xml><?xml version="1.0" encoding="utf-8"?>
-<p:notes xmlns:a="http://schemas.openxmlformats.org/drawingml/2006/main" xmlns:p="http://schemas.openxmlformats.org/presentationml/2006/main" xmlns:r="http://schemas.openxmlformats.org/officeDocument/2006/relationships">
-  <p:cSld>
-    <p:spTree>
-      <p:nvGrpSpPr>
-        <p:cNvPr id="1" name=""/>
-        <p:cNvGrpSpPr/>
-        <p:nvPr/>
-      </p:nvGrpSpPr>
-      <p:grpSpPr>
-        <a:xfrm>
-          <a:off x="0" y="0"/>
-          <a:ext cx="0" cy="0"/>
-          <a:chOff x="0" y="0"/>
-          <a:chExt cx="0" cy="0"/>
-        </a:xfrm>
-      </p:grpSpPr>
-      <p:sp>
-        <p:nvSpPr>
-          <p:cNvPr id="2" name="Slide Image Placeholder 1"/>
-          <p:cNvSpPr>
-            <a:spLocks noGrp="1"/>
-          </p:cNvSpPr>
-          <p:nvPr>
-            <p:ph type="sldImg" idx="2"/>
-          </p:nvPr>
-        </p:nvSpPr>
-        <p:spPr/>
-      </p:sp>
-      <p:sp>
-        <p:nvSpPr>
-          <p:cNvPr id="3" name="Notes Placeholder 2"/>
-          <p:cNvSpPr>
-            <a:spLocks noGrp="1"/>
-          </p:cNvSpPr>
-          <p:nvPr>
-            <p:ph type="body" idx="3" sz="quarter"/>
-          </p:nvPr>
-        </p:nvSpPr>
-        <p:spPr/>
-        <p:txBody>
-          <a:bodyPr/>
-          <a:lstStyle/>
-          <a:p>
-            <a:r>
-              <a:t>Licence, privacy, quality, ethics and reproducibility as required by the M2 outline.</a:t>
-            </a:r>
-          </a:p>
-        </p:txBody>
-      </p:sp>
-      <p:sp>
-        <p:nvSpPr>
-          <p:cNvPr id="4" name="Slide Number Placeholder 3"/>
-          <p:cNvSpPr>
-            <a:spLocks noGrp="1"/>
-          </p:cNvSpPr>
-          <p:nvPr>
-            <p:ph type="sldNum" idx="5" sz="quarter"/>
-          </p:nvPr>
-        </p:nvSpPr>
-        <p:spPr/>
-      </p:sp>
-    </p:spTree>
-  </p:cSld>
-  <p:clrMapOvr>
-    <a:masterClrMapping/>
-  </p:clrMapOvr>
-</p:notes>
-</file>
-
-<file path=ppt/notesSlides/notesSlide5.xml><?xml version="1.0" encoding="utf-8"?>
-<p:notes xmlns:a="http://schemas.openxmlformats.org/drawingml/2006/main" xmlns:p="http://schemas.openxmlformats.org/presentationml/2006/main" xmlns:r="http://schemas.openxmlformats.org/officeDocument/2006/relationships">
-  <p:cSld>
-    <p:spTree>
-      <p:nvGrpSpPr>
-        <p:cNvPr id="1" name=""/>
-        <p:cNvGrpSpPr/>
-        <p:nvPr/>
-      </p:nvGrpSpPr>
-      <p:grpSpPr>
-        <a:xfrm>
-          <a:off x="0" y="0"/>
-          <a:ext cx="0" cy="0"/>
-          <a:chOff x="0" y="0"/>
-          <a:chExt cx="0" cy="0"/>
-        </a:xfrm>
-      </p:grpSpPr>
-      <p:sp>
-        <p:nvSpPr>
-          <p:cNvPr id="2" name="Slide Image Placeholder 1"/>
-          <p:cNvSpPr>
-            <a:spLocks noGrp="1"/>
-          </p:cNvSpPr>
-          <p:nvPr>
-            <p:ph type="sldImg" idx="2"/>
-          </p:nvPr>
-        </p:nvSpPr>
-        <p:spPr/>
-      </p:sp>
-      <p:sp>
-        <p:nvSpPr>
-          <p:cNvPr id="3" name="Notes Placeholder 2"/>
-          <p:cNvSpPr>
-            <a:spLocks noGrp="1"/>
-          </p:cNvSpPr>
-          <p:nvPr>
-            <p:ph type="body" idx="3" sz="quarter"/>
-          </p:nvPr>
-        </p:nvSpPr>
-        <p:spPr/>
-        <p:txBody>
-          <a:bodyPr/>
-          <a:lstStyle/>
-          <a:p>
-            <a:r>
-              <a:t>Missing values are publisher suppression or NA cells; no exact or key duplicates in any table.</a:t>
-            </a:r>
-          </a:p>
-        </p:txBody>
-      </p:sp>
-      <p:sp>
-        <p:nvSpPr>
-          <p:cNvPr id="4" name="Slide Number Placeholder 3"/>
-          <p:cNvSpPr>
-            <a:spLocks noGrp="1"/>
-          </p:cNvSpPr>
-          <p:nvPr>
-            <p:ph type="sldNum" idx="5" sz="quarter"/>
-          </p:nvPr>
-        </p:nvSpPr>
-        <p:spPr/>
-      </p:sp>
-    </p:spTree>
-  </p:cSld>
-  <p:clrMapOvr>
-    <a:masterClrMapping/>
-  </p:clrMapOvr>
-</p:notes>
-</file>
-
-<file path=ppt/notesSlides/notesSlide6.xml><?xml version="1.0" encoding="utf-8"?>
-<p:notes xmlns:a="http://schemas.openxmlformats.org/drawingml/2006/main" xmlns:p="http://schemas.openxmlformats.org/presentationml/2006/main" xmlns:r="http://schemas.openxmlformats.org/officeDocument/2006/relationships">
-  <p:cSld>
-    <p:spTree>
-      <p:nvGrpSpPr>
-        <p:cNvPr id="1" name=""/>
-        <p:cNvGrpSpPr/>
-        <p:nvPr/>
-      </p:nvGrpSpPr>
-      <p:grpSpPr>
-        <a:xfrm>
-          <a:off x="0" y="0"/>
-          <a:ext cx="0" cy="0"/>
-          <a:chOff x="0" y="0"/>
-          <a:chExt cx="0" cy="0"/>
-        </a:xfrm>
-      </p:grpSpPr>
-      <p:sp>
-        <p:nvSpPr>
-          <p:cNvPr id="2" name="Slide Image Placeholder 1"/>
-          <p:cNvSpPr>
-            <a:spLocks noGrp="1"/>
-          </p:cNvSpPr>
-          <p:nvPr>
-            <p:ph type="sldImg" idx="2"/>
-          </p:nvPr>
-        </p:nvSpPr>
-        <p:spPr/>
-      </p:sp>
-      <p:sp>
-        <p:nvSpPr>
-          <p:cNvPr id="3" name="Notes Placeholder 2"/>
-          <p:cNvSpPr>
-            <a:spLocks noGrp="1"/>
-          </p:cNvSpPr>
-          <p:nvPr>
-            <p:ph type="body" idx="3" sz="quarter"/>
-          </p:nvPr>
-        </p:nvSpPr>
-        <p:spPr/>
-        <p:txBody>
-          <a:bodyPr/>
-          <a:lstStyle/>
-          <a:p>
-            <a:r>
-              <a:t>Factsheet marks 25–49-case estimates as (29.5); the API CSV renders -29.5. Corrected and flagged.</a:t>
-            </a:r>
-          </a:p>
-        </p:txBody>
-      </p:sp>
-      <p:sp>
-        <p:nvSpPr>
-          <p:cNvPr id="4" name="Slide Number Placeholder 3"/>
-          <p:cNvSpPr>
-            <a:spLocks noGrp="1"/>
-          </p:cNvSpPr>
-          <p:nvPr>
-            <p:ph type="sldNum" idx="5" sz="quarter"/>
-          </p:nvPr>
-        </p:nvSpPr>
-        <p:spPr/>
-      </p:sp>
-    </p:spTree>
-  </p:cSld>
-  <p:clrMapOvr>
-    <a:masterClrMapping/>
-  </p:clrMapOvr>
-</p:notes>
-</file>
-
-<file path=ppt/notesSlides/notesSlide7.xml><?xml version="1.0" encoding="utf-8"?>
-<p:notes xmlns:a="http://schemas.openxmlformats.org/drawingml/2006/main" xmlns:p="http://schemas.openxmlformats.org/presentationml/2006/main" xmlns:r="http://schemas.openxmlformats.org/officeDocument/2006/relationships">
-  <p:cSld>
-    <p:spTree>
-      <p:nvGrpSpPr>
-        <p:cNvPr id="1" name=""/>
-        <p:cNvGrpSpPr/>
-        <p:nvPr/>
-      </p:nvGrpSpPr>
-      <p:grpSpPr>
-        <a:xfrm>
-          <a:off x="0" y="0"/>
-          <a:ext cx="0" cy="0"/>
-          <a:chOff x="0" y="0"/>
-          <a:chExt cx="0" cy="0"/>
-        </a:xfrm>
-      </p:grpSpPr>
-      <p:sp>
-        <p:nvSpPr>
-          <p:cNvPr id="2" name="Slide Image Placeholder 1"/>
-          <p:cNvSpPr>
-            <a:spLocks noGrp="1"/>
-          </p:cNvSpPr>
-          <p:nvPr>
-            <p:ph type="sldImg" idx="2"/>
-          </p:nvPr>
-        </p:nvSpPr>
-        <p:spPr/>
-      </p:sp>
-      <p:sp>
-        <p:nvSpPr>
-          <p:cNvPr id="3" name="Notes Placeholder 2"/>
-          <p:cNvSpPr>
-            <a:spLocks noGrp="1"/>
-          </p:cNvSpPr>
-          <p:nvPr>
-            <p:ph type="body" idx="3" sz="quarter"/>
-          </p:nvPr>
-        </p:nvSpPr>
-        <p:spPr/>
-        <p:txBody>
-          <a:bodyPr/>
-          <a:lstStyle/>
-          <a:p>
-            <a:r>
-              <a:t>Associations only; the agent must not present them as causes.</a:t>
-            </a:r>
-          </a:p>
-        </p:txBody>
-      </p:sp>
-      <p:sp>
-        <p:nvSpPr>
-          <p:cNvPr id="4" name="Slide Number Placeholder 3"/>
-          <p:cNvSpPr>
-            <a:spLocks noGrp="1"/>
-          </p:cNvSpPr>
-          <p:nvPr>
-            <p:ph type="sldNum" idx="5" sz="quarter"/>
-          </p:nvPr>
-        </p:nvSpPr>
-        <p:spPr/>
-      </p:sp>
-    </p:spTree>
-  </p:cSld>
-  <p:clrMapOvr>
-    <a:masterClrMapping/>
-  </p:clrMapOvr>
-</p:notes>
-</file>
-
-<file path=ppt/notesSlides/notesSlide8.xml><?xml version="1.0" encoding="utf-8"?>
-<p:notes xmlns:a="http://schemas.openxmlformats.org/drawingml/2006/main" xmlns:p="http://schemas.openxmlformats.org/presentationml/2006/main" xmlns:r="http://schemas.openxmlformats.org/officeDocument/2006/relationships">
-  <p:cSld>
-    <p:spTree>
-      <p:nvGrpSpPr>
-        <p:cNvPr id="1" name=""/>
-        <p:cNvGrpSpPr/>
-        <p:nvPr/>
-      </p:nvGrpSpPr>
-      <p:grpSpPr>
-        <a:xfrm>
-          <a:off x="0" y="0"/>
-          <a:ext cx="0" cy="0"/>
-          <a:chOff x="0" y="0"/>
-          <a:chExt cx="0" cy="0"/>
-        </a:xfrm>
-      </p:grpSpPr>
-      <p:sp>
-        <p:nvSpPr>
-          <p:cNvPr id="2" name="Slide Image Placeholder 1"/>
-          <p:cNvSpPr>
-            <a:spLocks noGrp="1"/>
-          </p:cNvSpPr>
-          <p:nvPr>
-            <p:ph type="sldImg" idx="2"/>
-          </p:nvPr>
-        </p:nvSpPr>
-        <p:spPr/>
-      </p:sp>
-      <p:sp>
-        <p:nvSpPr>
-          <p:cNvPr id="3" name="Notes Placeholder 2"/>
-          <p:cNvSpPr>
-            <a:spLocks noGrp="1"/>
-          </p:cNvSpPr>
-          <p:nvPr>
-            <p:ph type="body" idx="3" sz="quarter"/>
-          </p:nvPr>
-        </p:nvSpPr>
-        <p:spPr/>
-        <p:txBody>
-          <a:bodyPr/>
-          <a:lstStyle/>
-          <a:p>
-            <a:r>
-              <a:t>scripts/preprocess_data.py (NFHS-5, Mandi, NCRB); src/analyst/data/loaders.py (IMD, PLFS).</a:t>
-            </a:r>
-          </a:p>
-        </p:txBody>
-      </p:sp>
-      <p:sp>
-        <p:nvSpPr>
-          <p:cNvPr id="4" name="Slide Number Placeholder 3"/>
-          <p:cNvSpPr>
-            <a:spLocks noGrp="1"/>
-          </p:cNvSpPr>
-          <p:nvPr>
-            <p:ph type="sldNum" idx="5" sz="quarter"/>
-          </p:nvPr>
-        </p:nvSpPr>
-        <p:spPr/>
-      </p:sp>
-    </p:spTree>
-  </p:cSld>
-  <p:clrMapOvr>
-    <a:masterClrMapping/>
-  </p:clrMapOvr>
-</p:notes>
-</file>
-
-<file path=ppt/notesSlides/notesSlide9.xml><?xml version="1.0" encoding="utf-8"?>
-<p:notes xmlns:a="http://schemas.openxmlformats.org/drawingml/2006/main" xmlns:p="http://schemas.openxmlformats.org/presentationml/2006/main" xmlns:r="http://schemas.openxmlformats.org/officeDocument/2006/relationships">
-  <p:cSld>
-    <p:spTree>
-      <p:nvGrpSpPr>
-        <p:cNvPr id="1" name=""/>
-        <p:cNvGrpSpPr/>
-        <p:nvPr/>
-      </p:nvGrpSpPr>
-      <p:grpSpPr>
-        <a:xfrm>
-          <a:off x="0" y="0"/>
-          <a:ext cx="0" cy="0"/>
-          <a:chOff x="0" y="0"/>
-          <a:chExt cx="0" cy="0"/>
-        </a:xfrm>
-      </p:grpSpPr>
-      <p:sp>
-        <p:nvSpPr>
-          <p:cNvPr id="2" name="Slide Image Placeholder 1"/>
-          <p:cNvSpPr>
-            <a:spLocks noGrp="1"/>
-          </p:cNvSpPr>
-          <p:nvPr>
-            <p:ph type="sldImg" idx="2"/>
-          </p:nvPr>
-        </p:nvSpPr>
-        <p:spPr/>
-      </p:sp>
-      <p:sp>
-        <p:nvSpPr>
-          <p:cNvPr id="3" name="Notes Placeholder 2"/>
-          <p:cNvSpPr>
-            <a:spLocks noGrp="1"/>
-          </p:cNvSpPr>
-          <p:nvPr>
-            <p:ph type="body" idx="3" sz="quarter"/>
-          </p:nvPr>
-        </p:nvSpPr>
-        <p:spPr/>
-        <p:txBody>
-          <a:bodyPr/>
-          <a:lstStyle/>
-          <a:p>
-            <a:r>
-              <a:t>Kev JSONL contract; labels by deterministic rules from labelling guide v1.</a:t>
-            </a:r>
-          </a:p>
-        </p:txBody>
-      </p:sp>
-      <p:sp>
-        <p:nvSpPr>
-          <p:cNvPr id="4" name="Slide Number Placeholder 3"/>
-          <p:cNvSpPr>
-            <a:spLocks noGrp="1"/>
-          </p:cNvSpPr>
-          <p:nvPr>
-            <p:ph type="sldNum" idx="5" sz="quarter"/>
-          </p:nvPr>
-        </p:nvSpPr>
-        <p:spPr/>
-      </p:sp>
-    </p:spTree>
-  </p:cSld>
-  <p:clrMapOvr>
-    <a:masterClrMapping/>
-  </p:clrMapOvr>
-</p:notes>
 </file>
 
 <file path=ppt/slideLayouts/slideLayout1.xml><?xml version="1.0" encoding="utf-8"?>
@@ -6689,7 +5370,7 @@
         </p:xfrm>
         <a:graphic>
           <a:graphicData uri="http://schemas.openxmlformats.org/drawingml/2006/chart">
-            <c:chart xmlns:c="http://schemas.openxmlformats.org/drawingml/2006/chart" r:id="rId3"/>
+            <c:chart xmlns:c="http://schemas.openxmlformats.org/drawingml/2006/chart" r:id="rId2"/>
           </a:graphicData>
         </a:graphic>
       </p:graphicFrame>
@@ -6789,7 +5470,7 @@
                 </a:solidFill>
                 <a:latin typeface="Calibri"/>
               </a:rPr>
-              <a:t>68 of 70 answerable NFHS-5 and Mandi queries return rows; the other 2 correctly return none on this data. NCRB-GOLD</a:t>
+              <a:t>88 of 90 answerable queries return rows; the other 2 correctly return none on this data.</a:t>
             </a:r>
           </a:p>
           <a:p>
@@ -7204,7 +5885,7 @@
                           </a:solidFill>
                           <a:latin typeface="Calibri"/>
                         </a:rPr>
-                        <a:t>Runs end to end on the v1 format (4 steps, 3.29 GB peak device memory); no accuracy claimed</a:t>
+                        <a:t>Runs end to end on 64 week-1 records in the v1 format (4 steps, 3.29 GB peak device memory); no accuracy claimed</a:t>
                       </a:r>
                     </a:p>
                   </a:txBody>
@@ -7299,7 +5980,7 @@
                 </a:solidFill>
                 <a:latin typeface="Calibri"/>
               </a:rPr>
-              <a:t>Takeaway: </a:t>
+              <a:t>Consequence: </a:t>
             </a:r>
             <a:r>
               <a:rPr sz="1500" b="0" i="0">
@@ -7752,7 +6433,7 @@
                 </a:solidFill>
                 <a:latin typeface="Calibri"/>
               </a:rPr>
-              <a:t>Five of 8–12 tables; domain imbalance</a:t>
+              <a:t>PoC catalogue of five tables; domain imbalance</a:t>
             </a:r>
           </a:p>
           <a:p>
@@ -7911,7 +6592,7 @@
                 </a:solidFill>
                 <a:latin typeface="Calibri"/>
               </a:rPr>
-              <a:t>v0 baseline on the reference pairs</a:t>
+              <a:t>PoC on the five tables: v0 baseline on the reference pairs</a:t>
             </a:r>
           </a:p>
           <a:p>
@@ -7945,7 +6626,7 @@
                 </a:solidFill>
                 <a:latin typeface="Calibri"/>
               </a:rPr>
-              <a:t>Onboard remaining catalogue tables</a:t>
+              <a:t>Then prepare the identified extension tables, applying any curation change the PoC shows</a:t>
             </a:r>
           </a:p>
         </p:txBody>
@@ -8286,7 +6967,7 @@
                           </a:solidFill>
                           <a:latin typeface="Calibri"/>
                         </a:rPr>
-                        <a:t/>
+                        <a:t>29 Oct 2026</a:t>
                       </a:r>
                     </a:p>
                   </a:txBody>
@@ -8376,7 +7057,7 @@
                           </a:solidFill>
                           <a:latin typeface="Calibri"/>
                         </a:rPr>
-                        <a:t/>
+                        <a:t>29 Oct 2026</a:t>
                       </a:r>
                     </a:p>
                   </a:txBody>
@@ -8444,7 +7125,7 @@
                           </a:solidFill>
                           <a:latin typeface="Calibri"/>
                         </a:rPr>
-                        <a:t>PENDING-SHAONI</a:t>
+                        <a:t>Identify and verify candidate extension tables for the remaining domains (source, licence, format), to be added after the proof of concept.</a:t>
                       </a:r>
                     </a:p>
                   </a:txBody>
@@ -8466,7 +7147,7 @@
                           </a:solidFill>
                           <a:latin typeface="Calibri"/>
                         </a:rPr>
-                        <a:t/>
+                        <a:t>29 Oct 2026</a:t>
                       </a:r>
                     </a:p>
                   </a:txBody>
@@ -8534,7 +7215,7 @@
                           </a:solidFill>
                           <a:latin typeface="Calibri"/>
                         </a:rPr>
-                        <a:t>PENDING-ASHMIT</a:t>
+                        <a:t>Clean-clone run of the tests and pipeline, checksum check of the manifest, and review of the PR.</a:t>
                       </a:r>
                     </a:p>
                   </a:txBody>
@@ -8556,7 +7237,7 @@
                           </a:solidFill>
                           <a:latin typeface="Calibri"/>
                         </a:rPr>
-                        <a:t/>
+                        <a:t>29 Oct 2026</a:t>
                       </a:r>
                     </a:p>
                   </a:txBody>
@@ -8958,7 +7639,7 @@
                 </a:solidFill>
                 <a:latin typeface="Cambria"/>
               </a:rPr>
-              <a:t>94,147</a:t>
+              <a:t>94,150</a:t>
             </a:r>
           </a:p>
         </p:txBody>
@@ -8997,8 +7678,8 @@
                 </a:solidFill>
                 <a:latin typeface="Calibri"/>
               </a:rPr>
-              <a:t>cleaned rows across four
-tables (NCRB pending)</a:t>
+              <a:t>cleaned rows across
+the five tables</a:t>
             </a:r>
           </a:p>
         </p:txBody>
@@ -10377,7 +9058,7 @@
                           </a:solidFill>
                           <a:latin typeface="Calibri"/>
                         </a:rPr>
-                        <a:t>NCRB-ROWS</a:t>
+                        <a:t>3</a:t>
                       </a:r>
                     </a:p>
                   </a:txBody>
@@ -10481,7 +9162,7 @@
                 </a:solidFill>
                 <a:latin typeface="Calibri"/>
               </a:rPr>
-              <a:t>each exercises a convention that makes public statistics hard to use — sub-divisions vs States, July–June survey years as columns, suppressed and low-sample estimates, three levels of place names, internally checkable arithmetic.</a:t>
+              <a:t>each exercises a convention that makes public statistics hard to use: sub-divisions vs States, July–June survey years as columns, suppressed and low-sample estimates, three levels of place names, internally checkable arithmetic.</a:t>
             </a:r>
           </a:p>
           <a:p>
@@ -10497,7 +9178,7 @@
                 </a:solidFill>
                 <a:latin typeface="Calibri"/>
               </a:rPr>
-              <a:t>Not yet in the catalogue: </a:t>
+              <a:t>Scope: </a:t>
             </a:r>
             <a:r>
               <a:rPr sz="1400" b="0" i="0">
@@ -10506,7 +9187,7 @@
                 </a:solidFill>
                 <a:latin typeface="Calibri"/>
               </a:rPr>
-              <a:t>agriculture production and prices/economy (DES, MoSPI CPI/WPI, RBI DBIE); five of the planned 8–12 tables are prepared.</a:t>
+              <a:t>a proof of concept runs on these five first. Extension tables (crop production, CPI, state income, census denominators, district rainfall normals) are identified, and added once the PoC confirms the curation approach.</a:t>
             </a:r>
           </a:p>
         </p:txBody>
@@ -12075,7 +10756,7 @@
                           </a:solidFill>
                           <a:latin typeface="Calibri"/>
                         </a:rPr>
-                        <a:t>NCRB-MISSING</a:t>
+                        <a:t>0</a:t>
                       </a:r>
                     </a:p>
                   </a:txBody>
@@ -12097,7 +10778,7 @@
                           </a:solidFill>
                           <a:latin typeface="Calibri"/>
                         </a:rPr>
-                        <a:t>NCRB-DUP</a:t>
+                        <a:t>0</a:t>
                       </a:r>
                     </a:p>
                   </a:txBody>
@@ -12155,7 +10836,7 @@
                 </a:solidFill>
                 <a:latin typeface="Calibri"/>
               </a:rPr>
-              <a:t>is right-skewed and seasonal: July median 285 mm, December 3 mm; extremes kept.</a:t>
+              <a:t>is right-skewed and seasonal: July median 285 mm, December 3 mm. All 401 outliers are high values from the wettest sub-divisions; kept.</a:t>
             </a:r>
           </a:p>
           <a:p>
@@ -12194,7 +10875,7 @@
           <p:nvPr/>
         </p:nvPicPr>
         <p:blipFill>
-          <a:blip r:embed="rId3"/>
+          <a:blip r:embed="rId2"/>
           <a:stretch>
             <a:fillRect/>
           </a:stretch>
@@ -12218,7 +10899,7 @@
           <p:nvPr/>
         </p:nvPicPr>
         <p:blipFill>
-          <a:blip r:embed="rId4"/>
+          <a:blip r:embed="rId3"/>
           <a:stretch>
             <a:fillRect/>
           </a:stretch>
@@ -12902,7 +11583,7 @@
           <p:nvPr/>
         </p:nvPicPr>
         <p:blipFill>
-          <a:blip r:embed="rId3"/>
+          <a:blip r:embed="rId2"/>
           <a:stretch>
             <a:fillRect/>
           </a:stretch>
@@ -12952,7 +11633,7 @@
                 </a:solidFill>
                 <a:latin typeface="Calibri"/>
               </a:rPr>
-              <a:t>Electricity, improved sanitation, clean cooking fuel and women's schooling are positively correlated.</a:t>
+              <a:t>Electricity, improved sanitation, clean cooking fuel and women's schooling (10+ years) correlate positively (0.32 to 0.65).</a:t>
             </a:r>
           </a:p>
           <a:p>
@@ -12969,7 +11650,7 @@
                 </a:solidFill>
                 <a:latin typeface="Calibri"/>
               </a:rPr>
-              <a:t>Child stunting is negatively correlated with all of them.</a:t>
+              <a:t>Child stunting correlates negatively with all four (-0.42 to -0.54).</a:t>
             </a:r>
           </a:p>
           <a:p>
@@ -14711,7 +13392,7 @@
         </p:xfrm>
         <a:graphic>
           <a:graphicData uri="http://schemas.openxmlformats.org/drawingml/2006/chart">
-            <c:chart xmlns:c="http://schemas.openxmlformats.org/drawingml/2006/chart" r:id="rId3"/>
+            <c:chart xmlns:c="http://schemas.openxmlformats.org/drawingml/2006/chart" r:id="rId2"/>
           </a:graphicData>
         </a:graphic>
       </p:graphicFrame>
@@ -15168,324 +13849,4 @@
   </a:objectDefaults>
   <a:extraClrSchemeLst/>
 </a:theme>
-</file>
-
-<file path=ppt/theme/theme2.xml><?xml version="1.0" encoding="utf-8"?>
-<a:theme xmlns:a="http://schemas.openxmlformats.org/drawingml/2006/main" name="Office Theme">
-  <a:themeElements>
-    <a:clrScheme name="Office">
-      <a:dk1>
-        <a:sysClr val="windowText" lastClr="000000"/>
-      </a:dk1>
-      <a:lt1>
-        <a:sysClr val="window" lastClr="FFFFFF"/>
-      </a:lt1>
-      <a:dk2>
-        <a:srgbClr val="1F497D"/>
-      </a:dk2>
-      <a:lt2>
-        <a:srgbClr val="EEECE1"/>
-      </a:lt2>
-      <a:accent1>
-        <a:srgbClr val="4F81BD"/>
-      </a:accent1>
-      <a:accent2>
-        <a:srgbClr val="C0504D"/>
-      </a:accent2>
-      <a:accent3>
-        <a:srgbClr val="9BBB59"/>
-      </a:accent3>
-      <a:accent4>
-        <a:srgbClr val="8064A2"/>
-      </a:accent4>
-      <a:accent5>
-        <a:srgbClr val="4BACC6"/>
-      </a:accent5>
-      <a:accent6>
-        <a:srgbClr val="F79646"/>
-      </a:accent6>
-      <a:hlink>
-        <a:srgbClr val="0000FF"/>
-      </a:hlink>
-      <a:folHlink>
-        <a:srgbClr val="800080"/>
-      </a:folHlink>
-    </a:clrScheme>
-    <a:fontScheme name="Office">
-      <a:majorFont>
-        <a:latin typeface="Calibri"/>
-        <a:ea typeface=""/>
-        <a:cs typeface=""/>
-        <a:font script="Jpan" typeface="ＭＳ Ｐゴシック"/>
-        <a:font script="Hang" typeface="맑은 고딕"/>
-        <a:font script="Hans" typeface="宋体"/>
-        <a:font script="Hant" typeface="新細明體"/>
-        <a:font script="Arab" typeface="Times New Roman"/>
-        <a:font script="Hebr" typeface="Times New Roman"/>
-        <a:font script="Thai" typeface="Angsana New"/>
-        <a:font script="Ethi" typeface="Nyala"/>
-        <a:font script="Beng" typeface="Vrinda"/>
-        <a:font script="Gujr" typeface="Shruti"/>
-        <a:font script="Khmr" typeface="MoolBoran"/>
-        <a:font script="Knda" typeface="Tunga"/>
-        <a:font script="Guru" typeface="Raavi"/>
-        <a:font script="Cans" typeface="Euphemia"/>
-        <a:font script="Cher" typeface="Plantagenet Cherokee"/>
-        <a:font script="Yiii" typeface="Microsoft Yi Baiti"/>
-        <a:font script="Tibt" typeface="Microsoft Himalaya"/>
-        <a:font script="Thaa" typeface="MV Boli"/>
-        <a:font script="Deva" typeface="Mangal"/>
-        <a:font script="Telu" typeface="Gautami"/>
-        <a:font script="Taml" typeface="Latha"/>
-        <a:font script="Syrc" typeface="Estrangelo Edessa"/>
-        <a:font script="Orya" typeface="Kalinga"/>
-        <a:font script="Mlym" typeface="Kartika"/>
-        <a:font script="Laoo" typeface="DokChampa"/>
-        <a:font script="Sinh" typeface="Iskoola Pota"/>
-        <a:font script="Mong" typeface="Mongolian Baiti"/>
-        <a:font script="Viet" typeface="Times New Roman"/>
-        <a:font script="Uigh" typeface="Microsoft Uighur"/>
-        <a:font script="Geor" typeface="Sylfaen"/>
-      </a:majorFont>
-      <a:minorFont>
-        <a:latin typeface="Calibri"/>
-        <a:ea typeface=""/>
-        <a:cs typeface=""/>
-        <a:font script="Jpan" typeface="ＭＳ Ｐゴシック"/>
-        <a:font script="Hang" typeface="맑은 고딕"/>
-        <a:font script="Hans" typeface="宋体"/>
-        <a:font script="Hant" typeface="新細明體"/>
-        <a:font script="Arab" typeface="Arial"/>
-        <a:font script="Hebr" typeface="Arial"/>
-        <a:font script="Thai" typeface="Cordia New"/>
-        <a:font script="Ethi" typeface="Nyala"/>
-        <a:font script="Beng" typeface="Vrinda"/>
-        <a:font script="Gujr" typeface="Shruti"/>
-        <a:font script="Khmr" typeface="DaunPenh"/>
-        <a:font script="Knda" typeface="Tunga"/>
-        <a:font script="Guru" typeface="Raavi"/>
-        <a:font script="Cans" typeface="Euphemia"/>
-        <a:font script="Cher" typeface="Plantagenet Cherokee"/>
-        <a:font script="Yiii" typeface="Microsoft Yi Baiti"/>
-        <a:font script="Tibt" typeface="Microsoft Himalaya"/>
-        <a:font script="Thaa" typeface="MV Boli"/>
-        <a:font script="Deva" typeface="Mangal"/>
-        <a:font script="Telu" typeface="Gautami"/>
-        <a:font script="Taml" typeface="Latha"/>
-        <a:font script="Syrc" typeface="Estrangelo Edessa"/>
-        <a:font script="Orya" typeface="Kalinga"/>
-        <a:font script="Mlym" typeface="Kartika"/>
-        <a:font script="Laoo" typeface="DokChampa"/>
-        <a:font script="Sinh" typeface="Iskoola Pota"/>
-        <a:font script="Mong" typeface="Mongolian Baiti"/>
-        <a:font script="Viet" typeface="Arial"/>
-        <a:font script="Uigh" typeface="Microsoft Uighur"/>
-        <a:font script="Geor" typeface="Sylfaen"/>
-      </a:minorFont>
-    </a:fontScheme>
-    <a:fmtScheme name="Office">
-      <a:fillStyleLst>
-        <a:solidFill>
-          <a:schemeClr val="phClr"/>
-        </a:solidFill>
-        <a:gradFill rotWithShape="1">
-          <a:gsLst>
-            <a:gs pos="0">
-              <a:schemeClr val="phClr">
-                <a:tint val="50000"/>
-                <a:satMod val="300000"/>
-              </a:schemeClr>
-            </a:gs>
-            <a:gs pos="35000">
-              <a:schemeClr val="phClr">
-                <a:tint val="37000"/>
-                <a:satMod val="300000"/>
-              </a:schemeClr>
-            </a:gs>
-            <a:gs pos="100000">
-              <a:schemeClr val="phClr">
-                <a:tint val="15000"/>
-                <a:satMod val="350000"/>
-              </a:schemeClr>
-            </a:gs>
-          </a:gsLst>
-          <a:lin ang="16200000" scaled="1"/>
-        </a:gradFill>
-        <a:gradFill rotWithShape="1">
-          <a:gsLst>
-            <a:gs pos="0">
-              <a:schemeClr val="phClr">
-                <a:tint val="100000"/>
-                <a:shade val="100000"/>
-                <a:satMod val="130000"/>
-              </a:schemeClr>
-            </a:gs>
-            <a:gs pos="100000">
-              <a:schemeClr val="phClr">
-                <a:tint val="50000"/>
-                <a:shade val="100000"/>
-                <a:satMod val="350000"/>
-              </a:schemeClr>
-            </a:gs>
-          </a:gsLst>
-          <a:lin ang="16200000" scaled="0"/>
-        </a:gradFill>
-      </a:fillStyleLst>
-      <a:lnStyleLst>
-        <a:ln w="9525" cap="flat" cmpd="sng" algn="ctr">
-          <a:solidFill>
-            <a:schemeClr val="phClr">
-              <a:shade val="95000"/>
-              <a:satMod val="105000"/>
-            </a:schemeClr>
-          </a:solidFill>
-          <a:prstDash val="solid"/>
-        </a:ln>
-        <a:ln w="25400" cap="flat" cmpd="sng" algn="ctr">
-          <a:solidFill>
-            <a:schemeClr val="phClr"/>
-          </a:solidFill>
-          <a:prstDash val="solid"/>
-        </a:ln>
-        <a:ln w="38100" cap="flat" cmpd="sng" algn="ctr">
-          <a:solidFill>
-            <a:schemeClr val="phClr"/>
-          </a:solidFill>
-          <a:prstDash val="solid"/>
-        </a:ln>
-      </a:lnStyleLst>
-      <a:effectStyleLst>
-        <a:effectStyle>
-          <a:effectLst>
-            <a:outerShdw blurRad="40000" dist="20000" dir="5400000" rotWithShape="0">
-              <a:srgbClr val="000000">
-                <a:alpha val="38000"/>
-              </a:srgbClr>
-            </a:outerShdw>
-          </a:effectLst>
-        </a:effectStyle>
-        <a:effectStyle>
-          <a:effectLst>
-            <a:outerShdw blurRad="40000" dist="23000" dir="5400000" rotWithShape="0">
-              <a:srgbClr val="000000">
-                <a:alpha val="35000"/>
-              </a:srgbClr>
-            </a:outerShdw>
-          </a:effectLst>
-        </a:effectStyle>
-        <a:effectStyle>
-          <a:effectLst>
-            <a:outerShdw blurRad="40000" dist="23000" dir="5400000" rotWithShape="0">
-              <a:srgbClr val="000000">
-                <a:alpha val="35000"/>
-              </a:srgbClr>
-            </a:outerShdw>
-          </a:effectLst>
-          <a:scene3d>
-            <a:camera prst="orthographicFront">
-              <a:rot lat="0" lon="0" rev="0"/>
-            </a:camera>
-            <a:lightRig rig="threePt" dir="t">
-              <a:rot lat="0" lon="0" rev="1200000"/>
-            </a:lightRig>
-          </a:scene3d>
-          <a:sp3d>
-            <a:bevelT w="63500" h="25400"/>
-          </a:sp3d>
-        </a:effectStyle>
-      </a:effectStyleLst>
-      <a:bgFillStyleLst>
-        <a:solidFill>
-          <a:schemeClr val="phClr"/>
-        </a:solidFill>
-        <a:gradFill rotWithShape="1">
-          <a:gsLst>
-            <a:gs pos="0">
-              <a:schemeClr val="phClr">
-                <a:tint val="40000"/>
-                <a:satMod val="350000"/>
-              </a:schemeClr>
-            </a:gs>
-            <a:gs pos="40000">
-              <a:schemeClr val="phClr">
-                <a:tint val="45000"/>
-                <a:shade val="99000"/>
-                <a:satMod val="350000"/>
-              </a:schemeClr>
-            </a:gs>
-            <a:gs pos="100000">
-              <a:schemeClr val="phClr">
-                <a:shade val="20000"/>
-                <a:satMod val="255000"/>
-              </a:schemeClr>
-            </a:gs>
-          </a:gsLst>
-          <a:path path="circle">
-            <a:fillToRect l="50000" t="-80000" r="50000" b="180000"/>
-          </a:path>
-        </a:gradFill>
-        <a:gradFill rotWithShape="1">
-          <a:gsLst>
-            <a:gs pos="0">
-              <a:schemeClr val="phClr">
-                <a:tint val="80000"/>
-                <a:satMod val="300000"/>
-              </a:schemeClr>
-            </a:gs>
-            <a:gs pos="100000">
-              <a:schemeClr val="phClr">
-                <a:shade val="30000"/>
-                <a:satMod val="200000"/>
-              </a:schemeClr>
-            </a:gs>
-          </a:gsLst>
-          <a:path path="circle">
-            <a:fillToRect l="50000" t="50000" r="50000" b="50000"/>
-          </a:path>
-        </a:gradFill>
-      </a:bgFillStyleLst>
-    </a:fmtScheme>
-  </a:themeElements>
-  <a:objectDefaults>
-    <a:spDef>
-      <a:spPr/>
-      <a:bodyPr/>
-      <a:lstStyle/>
-      <a:style>
-        <a:lnRef idx="1">
-          <a:schemeClr val="accent1"/>
-        </a:lnRef>
-        <a:fillRef idx="3">
-          <a:schemeClr val="accent1"/>
-        </a:fillRef>
-        <a:effectRef idx="2">
-          <a:schemeClr val="accent1"/>
-        </a:effectRef>
-        <a:fontRef idx="minor">
-          <a:schemeClr val="lt1"/>
-        </a:fontRef>
-      </a:style>
-    </a:spDef>
-    <a:lnDef>
-      <a:spPr/>
-      <a:bodyPr/>
-      <a:lstStyle/>
-      <a:style>
-        <a:lnRef idx="2">
-          <a:schemeClr val="accent1"/>
-        </a:lnRef>
-        <a:fillRef idx="0">
-          <a:schemeClr val="accent1"/>
-        </a:fillRef>
-        <a:effectRef idx="1">
-          <a:schemeClr val="accent1"/>
-        </a:effectRef>
-        <a:fontRef idx="minor">
-          <a:schemeClr val="tx1"/>
-        </a:fontRef>
-      </a:style>
-    </a:lnDef>
-  </a:objectDefaults>
-  <a:extraClrSchemeLst/>
-</a:theme>
 </file>
</xml_diff>